<commit_message>
Replace all English terms with Chinese equivalents in presentation
Co-authored-by: 12zhengwei <83262252+12zhengwei@users.noreply.github.com>
</commit_message>
<xml_diff>
--- a/金陵购车节政企通补贴平台合作方案.pptx
+++ b/金陵购车节政企通补贴平台合作方案.pptx
@@ -3463,7 +3463,7 @@
               </a:defRPr>
             </a:pPr>
             <a:r>
-              <a:t>批量获取了高质量车主客户，并成功带动了信用卡、贷款、App活跃度等多项业务指标的增长</a:t>
+              <a:t>批量获取了高质量车主客户，并成功带动了信用卡、贷款、手机应用活跃度等多项业务指标的增长</a:t>
             </a:r>
           </a:p>
           <a:p>
@@ -4152,7 +4152,7 @@
               </a:defRPr>
             </a:pPr>
             <a:r>
-              <a:t>"政府搭台、银行助力"模式可快速起量，我行App可作为核心载体</a:t>
+              <a:t>"政府搭台、银行助力"模式可快速起量，我行手机应用可作为核心载体</a:t>
             </a:r>
           </a:p>
           <a:p>
@@ -4356,7 +4356,7 @@
               </a:defRPr>
             </a:pPr>
             <a:r>
-              <a:t>▶ C端用户入口</a:t>
+              <a:t>▶ 客户端用户入口</a:t>
             </a:r>
           </a:p>
           <a:p>
@@ -4371,7 +4371,7 @@
               </a:defRPr>
             </a:pPr>
             <a:r>
-              <a:t>"补贴申请"小程序（内嵌于招行App或微信生态）</a:t>
+              <a:t>"补贴申请"小程序（内嵌于招行手机应用或微信生态）</a:t>
             </a:r>
           </a:p>
           <a:p>
@@ -4401,7 +4401,7 @@
               </a:defRPr>
             </a:pPr>
             <a:r>
-              <a:t>▶ B端管理后台</a:t>
+              <a:t>▶ 管理端后台</a:t>
             </a:r>
           </a:p>
           <a:p>
@@ -4605,7 +4605,7 @@
               </a:defRPr>
             </a:pPr>
             <a:r>
-              <a:t>从招行App/小程序进入，一键授权登录</a:t>
+              <a:t>从招行手机应用/小程序进入，一键授权登录</a:t>
             </a:r>
           </a:p>
           <a:p>
@@ -4635,7 +4635,7 @@
               </a:defRPr>
             </a:pPr>
             <a:r>
-              <a:t>OCR识别行驶证/购车发票，用户确认</a:t>
+              <a:t>光学字符识别技术识别行驶证/购车发票，用户确认</a:t>
             </a:r>
           </a:p>
           <a:p>
@@ -4665,7 +4665,7 @@
               </a:defRPr>
             </a:pPr>
             <a:r>
-              <a:t>OCR识别人脸/身份证，与公安系统联网核验</a:t>
+              <a:t>光学字符识别技术识别人脸/身份证，与公安系统联网核验</a:t>
             </a:r>
           </a:p>
           <a:p>
@@ -4892,7 +4892,7 @@
               </a:defRPr>
             </a:pPr>
             <a:r>
-              <a:t>借助OCR和大数据技术，自动识别和预填信息，减少用户操作，提升体验</a:t>
+              <a:t>借助光学字符识别和大数据技术，自动识别和预填信息，减少用户操作，提升体验</a:t>
             </a:r>
           </a:p>
           <a:p>
@@ -5179,7 +5179,7 @@
               </a:defRPr>
             </a:pPr>
             <a:r>
-              <a:t>实时展示申请总量、审核进度、补贴发放总额、客群分析等核心KPI</a:t>
+              <a:t>实时展示申请总量、审核进度、补贴发放总额、客群分析等核心关键绩效指标</a:t>
             </a:r>
             <a:br/>
             <a:r>
@@ -5330,7 +5330,7 @@
               </a:defRPr>
             </a:pPr>
             <a:r>
-              <a:t>文案："恭喜！您已获得XX万元招行备用金资格，购车消费更轻松！"</a:t>
+              <a:t>文案："恭喜！您已获得若干万元招行备用金资格，购车消费更轻松！"</a:t>
             </a:r>
           </a:p>
           <a:p>
@@ -5420,7 +5420,7 @@
               </a:defRPr>
             </a:pPr>
             <a:r>
-              <a:t>• App引流：</a:t>
+              <a:t>• 手机应用引流：</a:t>
             </a:r>
           </a:p>
           <a:p>
@@ -5435,7 +5435,7 @@
               </a:defRPr>
             </a:pPr>
             <a:r>
-              <a:t>整个流程设计优先在招行App内完成，补贴发放后，通过App消息推送引导用户参与其他活动（如本地生活优惠、理财产品推荐），提升App月活</a:t>
+              <a:t>整个流程设计优先在招行手机应用内完成，补贴发放后，通过手机应用消息推送引导用户参与其他活动（如本地生活优惠、理财产品推荐），提升手机应用月活</a:t>
             </a:r>
           </a:p>
           <a:p>
@@ -5465,7 +5465,7 @@
               </a:defRPr>
             </a:pPr>
             <a:r>
-              <a:t>实现"获客-活客-留客"闭环：通过本次活动获取新客，通过App互动激活客户，通过后续的综合金融服务留住客户</a:t>
+              <a:t>实现"获客-活客-留客"闭环：通过本次活动获取新客，通过手机应用互动激活客户，通过后续的综合金融服务留住客户</a:t>
             </a:r>
           </a:p>
         </p:txBody>

</xml_diff>